<commit_message>
Record verified Gemini scoring, complete official RAG, live app evidence and MS2 report
</commit_message>
<xml_diff>
--- a/docs/slides/Stepwise_MS2_Presentation_Final.pptx
+++ b/docs/slides/Stepwise_MS2_Presentation_Final.pptx
@@ -2,20 +2,20 @@
 <file path=ppt/presentation.xml><?xml version="1.0" encoding="utf-8"?>
 <p:presentation xmlns:p="http://schemas.openxmlformats.org/presentationml/2006/main">
   <p:sldMasterIdLst>
-    <p:sldMasterId xmlns:r="http://schemas.openxmlformats.org/officeDocument/2006/relationships" id="2147483648" r:id="Rb765a9847dcd41da"/>
+    <p:sldMasterId xmlns:r="http://schemas.openxmlformats.org/officeDocument/2006/relationships" id="2147483648" r:id="R35555c1953c14268"/>
   </p:sldMasterIdLst>
   <p:notesMasterIdLst>
-    <p:notesMasterId xmlns:r="http://schemas.openxmlformats.org/officeDocument/2006/relationships" r:id="R5ceca6e6586b44e9"/>
+    <p:notesMasterId xmlns:r="http://schemas.openxmlformats.org/officeDocument/2006/relationships" r:id="R0e7be3e3a6af470e"/>
   </p:notesMasterIdLst>
   <p:sldIdLst>
-    <p:sldId xmlns:r="http://schemas.openxmlformats.org/officeDocument/2006/relationships" id="256" r:id="R8849ef5db22c4ee3"/>
-    <p:sldId xmlns:r="http://schemas.openxmlformats.org/officeDocument/2006/relationships" id="257" r:id="R486c6e46e95e4950"/>
-    <p:sldId xmlns:r="http://schemas.openxmlformats.org/officeDocument/2006/relationships" id="258" r:id="Rce9ddc0f785341e3"/>
-    <p:sldId xmlns:r="http://schemas.openxmlformats.org/officeDocument/2006/relationships" id="259" r:id="Rce34afcbf1b54fa8"/>
-    <p:sldId xmlns:r="http://schemas.openxmlformats.org/officeDocument/2006/relationships" id="260" r:id="R64b69f16b56f4966"/>
-    <p:sldId xmlns:r="http://schemas.openxmlformats.org/officeDocument/2006/relationships" id="261" r:id="Red184b5fd0e14c12"/>
-    <p:sldId xmlns:r="http://schemas.openxmlformats.org/officeDocument/2006/relationships" id="262" r:id="R932f3b2267694af4"/>
-    <p:sldId xmlns:r="http://schemas.openxmlformats.org/officeDocument/2006/relationships" id="263" r:id="R081c2f4f2246462a"/>
+    <p:sldId xmlns:r="http://schemas.openxmlformats.org/officeDocument/2006/relationships" id="256" r:id="R2d6b16a5daeb4f76"/>
+    <p:sldId xmlns:r="http://schemas.openxmlformats.org/officeDocument/2006/relationships" id="257" r:id="R75f36225e7124b38"/>
+    <p:sldId xmlns:r="http://schemas.openxmlformats.org/officeDocument/2006/relationships" id="258" r:id="Re7e79a9b0ec04fd9"/>
+    <p:sldId xmlns:r="http://schemas.openxmlformats.org/officeDocument/2006/relationships" id="259" r:id="Rb81e5b87e53a45ef"/>
+    <p:sldId xmlns:r="http://schemas.openxmlformats.org/officeDocument/2006/relationships" id="260" r:id="Rb4acea4e9fbd45f5"/>
+    <p:sldId xmlns:r="http://schemas.openxmlformats.org/officeDocument/2006/relationships" id="261" r:id="Rd4d9612a36f64989"/>
+    <p:sldId xmlns:r="http://schemas.openxmlformats.org/officeDocument/2006/relationships" id="262" r:id="R7b6701e6eae54d86"/>
+    <p:sldId xmlns:r="http://schemas.openxmlformats.org/officeDocument/2006/relationships" id="263" r:id="R1c3418c8b3d74430"/>
   </p:sldIdLst>
   <p:sldSz cx="12192000" cy="6858000"/>
   <p:notesSz cx="6858000" cy="9144000"/>
@@ -449,7 +449,7 @@
           <a:lstStyle xmlns:a="http://schemas.openxmlformats.org/drawingml/2006/main"/>
           <a:p xmlns:a="http://schemas.openxmlformats.org/drawingml/2006/main">
             <a:r>
-              <a:t>AC215 Fall 2026 MS2. Team: Bei Li, Ernest Ferdian, Dimitris Pipinis, Xiahui Huang. Timing: 1 minute. Source: https://harvard-iacs.github.io/2026-AC215/milestone2/</a:t>
+              <a:t>1 minute. AC215 Fall 2026 MS2. Team: Bei Li, Ernest Ferdian, Dimitris Pipinis, Xiahui Huang. Typed/pasted IELTS Academic Task 2 only. Source: https://harvard-iacs.github.io/2026-AC215/milestone2/</a:t>
             </a:r>
           </a:p>
         </p:txBody>
@@ -519,7 +519,7 @@
           <a:lstStyle xmlns:a="http://schemas.openxmlformats.org/drawingml/2006/main"/>
           <a:p xmlns:a="http://schemas.openxmlformats.org/drawingml/2006/main">
             <a:r>
-              <a:t>2 minutes. Show compose.yaml and the five pyproject/uv.lock pairs. Reference: https://github.com/dlops-io/cheese-app-v0 and https://github.com/rahuldave/babykev.</a:t>
+              <a:t>2 minutes. Five custom Dockerfiles and five pyproject.toml/uv.lock pairs. Data services finish successfully before API/web start. Qdrant stores vectors persistently. Google Vertex AI performs actual inference; evidence validation rejects unchecked outputs. References: https://github.com/dlops-io/cheese-app-v0 and https://github.com/rahuldave/babykev. See compose.yaml and docs/setup.md.</a:t>
             </a:r>
           </a:p>
         </p:txBody>
@@ -589,7 +589,7 @@
           <a:lstStyle xmlns:a="http://schemas.openxmlformats.org/drawingml/2006/main"/>
           <a:p xmlns:a="http://schemas.openxmlformats.org/drawingml/2006/main">
             <a:r>
-              <a:t>2 minutes. Official source: https://ielts.org/cdn/ielts-guides/ielts-writing-band-descriptors.pdf. Candidate: https://huggingface.co/datasets/chillies/ielts-writing-task2-essays. Actual counts: docs/evidence/data_quality.json.</a:t>
+              <a:t>2 minutes. 131 total: 80 cells, 20 subcriteria, 5 definitions, 7 rules, 9 descriptor pages and 10 teaching pages. Both tasks are indexed for full source coverage; Task 1 is excluded from scoring. Sources: https://ielts.org/cdn/ielts-guides/ielts-writing-band-descriptors.pdf ; https://ielts.org/cdn/ielts-guides/ielts-writing-key-assessment-criteria.pdf ; https://takeielts.britishcouncil.org/sites/default/files/writing_task_2_-_answer_the_questions.pdf . The third source is older supplementary guidance. MS3 candidates are excluded. Evidence: docs/evidence/data_quality.json.</a:t>
             </a:r>
           </a:p>
         </p:txBody>
@@ -659,7 +659,7 @@
           <a:lstStyle xmlns:a="http://schemas.openxmlformats.org/drawingml/2006/main"/>
           <a:p xmlns:a="http://schemas.openxmlformats.org/drawingml/2006/main">
             <a:r>
-              <a:t>2 minutes. Open docs/evidence/retrieval_example.json. Half-band 6.5 maps to descriptors 6 and 7. Similarity ranks rubric context; it does not score the essay.</a:t>
+              <a:t>2 minutes. Demonstrate POST /api/retrieve with criterion TR and target 6.5. Returns bands 6 and 7. Scoring does not use the target: filtered mandatory coverage gets all 40 Task 2 cells, 20 checks and applicable definitions/rules; semantic search adds teaching context. Do not confuse cosine similarity with an essay score. Evidence: docs/evidence/retrieval_example.json and rag_verification.json. BAAI/bge-small-en-v1.5, CPU ONNX, 384 dimensions.</a:t>
             </a:r>
           </a:p>
         </p:txBody>
@@ -729,7 +729,7 @@
           <a:lstStyle xmlns:a="http://schemas.openxmlformats.org/drawingml/2006/main"/>
           <a:p xmlns:a="http://schemas.openxmlformats.org/drawingml/2006/main">
             <a:r>
-              <a:t>3 minutes together with the next slide. Live demo: typed/pasted sample -&gt; feedback -&gt; all four criterion tabs. MS2 suggestions are curated templates; actual model scoring is pending MS3.</a:t>
+              <a:t>2 minutes. Live sample: 273 words, overall 8.0 and four criterion scores 8. These are observed model outputs, not externally validated accuracy. Each tab gives exact original evidence, practical next steps and a revision. The right panel contains official subcriteria, not duplicated score summaries. Source/excerpt checks are structural; they cannot prove the model reasoning is correct. Evidence: docs/evidence/feedback_output.json and app-feedback.png.</a:t>
             </a:r>
           </a:p>
         </p:txBody>
@@ -799,7 +799,7 @@
           <a:lstStyle xmlns:a="http://schemas.openxmlformats.org/drawingml/2006/main"/>
           <a:p xmlns:a="http://schemas.openxmlformats.org/drawingml/2006/main">
             <a:r>
-              <a:t>Continue the 3-minute app demonstration. Submit target band, position and ideas; inspect/download the live backend writing brief. Full generation and separate scoring will be connected in MS3.</a:t>
+              <a:t>3 minutes. Show Goals: target band, position and ideas. Then show complete model essay. A separate fresh Gemini assessment receives only the question and essay, not target/generator notes. The target 7.0 essay was assessed 9.0. This proves the workflow and also exposes target deviation / calibration work. Show the score difference honestly; do not claim a certified score or guaranteed target match. Sources: docs/evidence/model_essay_request.json, model_essay_output.json, app-model.png.</a:t>
             </a:r>
           </a:p>
         </p:txBody>
@@ -869,7 +869,7 @@
           <a:lstStyle xmlns:a="http://schemas.openxmlformats.org/drawingml/2006/main"/>
           <a:p xmlns:a="http://schemas.openxmlformats.org/drawingml/2006/main">
             <a:r>
-              <a:t>3 minutes: show cloud instance/container screenshot and actual verification output. 9 local unit tests passed; live HTTP/vector assertions and idempotent rerun are recorded separately.</a:t>
+              <a:t>2 minutes. Dedicated project stepwise-ac215-20261010, Harvard self-paid folder, Vertex API and billing enabled. Cloud Shell is temporary, not a persistent production deployment. Source snapshot 3aea32a1828dd022, chunk snapshot 52814016b8103614, index 2da4e8eda6a331b5. Model gemini-3.8-flash. 12 workflow checks, 18 local unit tests, separate 40-case retrieval check. Weak essay 3.0 &lt; sample 8.0. Draft feedback 22.4 seconds in this one run. Receipts include response IDs and token counts. Source: docs/evidence/verification.json, index.json and pipeline.log.</a:t>
             </a:r>
           </a:p>
         </p:txBody>
@@ -939,7 +939,7 @@
           <a:lstStyle xmlns:a="http://schemas.openxmlformats.org/drawingml/2006/main"/>
           <a:p xmlns:a="http://schemas.openxmlformats.org/drawingml/2006/main">
             <a:r>
-              <a:t>2 minutes. Scope: open-weight baseline/LoRA experiments, approved training data, independent held-out evaluation, tracking and serving. Current retrieval is not a calibrated scorer.</a:t>
+              <a:t>1 minute. Audit data reuse, score provenance, near duplicates and prompt families before adaptation. Compare prompting vs official RAG vs open-model LoRA. Track criterion MAE, within-0.5 agreement, repeated-run variance, target deviation, latency and tokens. Current integration success is not scoring calibration. Every team member should understand the entire code and demo. Repository https://github.com/dwcqwcqw/stepwise/tree/milestone2 .</a:t>
             </a:r>
           </a:p>
         </p:txBody>
@@ -1007,7 +1007,7 @@
   </p:cSld>
   <p:clrMap bg1="lt1" tx1="dk1" bg2="lt2" tx2="dk2" accent1="accent1" accent2="accent2" accent3="accent3" accent4="accent4" accent5="accent5" accent6="accent6" hlink="hlink" folHlink="folHlink"/>
   <p:sldLayoutIdLst>
-    <p:sldLayoutId xmlns:r="http://schemas.openxmlformats.org/officeDocument/2006/relationships" id="2147483649" r:id="Re1db291c5fea47ed"/>
+    <p:sldLayoutId xmlns:r="http://schemas.openxmlformats.org/officeDocument/2006/relationships" id="2147483649" r:id="R1932e8c280bf4dc9"/>
   </p:sldLayoutIdLst>
   <p:txStyles>
     <p:titleStyle>
@@ -1558,7 +1558,7 @@
           <p:cNvPr id="5" name="">
             <a:extLst xmlns:a="http://schemas.openxmlformats.org/drawingml/2006/main">
               <a:ext uri="{FF2B5EF4-FFF2-40B4-BE49-F238E27FC236}">
-                <a16:creationId xmlns:a16="http://schemas.microsoft.com/office/drawing/2014/main" id="{EEA2850B-A663-46D2-B979-3F473CCE2E9D}"/>
+                <a16:creationId xmlns:a16="http://schemas.microsoft.com/office/drawing/2014/main" id="{E3D79ECF-E571-4657-BB81-30A26A8A5E12}"/>
               </a:ext>
             </a:extLst>
           </p:cNvPr>
@@ -1615,7 +1615,7 @@
           <p:cNvPr id="2" name="">
             <a:extLst xmlns:a="http://schemas.openxmlformats.org/drawingml/2006/main">
               <a:ext uri="{FF2B5EF4-FFF2-40B4-BE49-F238E27FC236}">
-                <a16:creationId xmlns:a16="http://schemas.microsoft.com/office/drawing/2014/main" id="{796508FE-C27B-4C9B-BE9C-FB713B48096E}"/>
+                <a16:creationId xmlns:a16="http://schemas.microsoft.com/office/drawing/2014/main" id="{C03DFFF9-0267-47D1-AC2F-97B9FCC1C19D}"/>
               </a:ext>
             </a:extLst>
           </p:cNvPr>
@@ -1695,7 +1695,7 @@
           <p:cNvPr id="3" name="">
             <a:extLst xmlns:a="http://schemas.openxmlformats.org/drawingml/2006/main">
               <a:ext uri="{FF2B5EF4-FFF2-40B4-BE49-F238E27FC236}">
-                <a16:creationId xmlns:a16="http://schemas.microsoft.com/office/drawing/2014/main" id="{7C3968DB-5706-4523-AD1F-7C8D1F70A95E}"/>
+                <a16:creationId xmlns:a16="http://schemas.microsoft.com/office/drawing/2014/main" id="{C2F1E136-9979-4DBD-BFAF-156207C2435B}"/>
               </a:ext>
             </a:extLst>
           </p:cNvPr>
@@ -1752,7 +1752,7 @@
           <p:cNvPr id="4" name="">
             <a:extLst xmlns:a="http://schemas.openxmlformats.org/drawingml/2006/main">
               <a:ext uri="{FF2B5EF4-FFF2-40B4-BE49-F238E27FC236}">
-                <a16:creationId xmlns:a16="http://schemas.microsoft.com/office/drawing/2014/main" id="{F736BD3F-79FB-4396-A9F1-625FEB49C18C}"/>
+                <a16:creationId xmlns:a16="http://schemas.microsoft.com/office/drawing/2014/main" id="{1653517E-E7A1-4605-A152-C2208135365C}"/>
               </a:ext>
             </a:extLst>
           </p:cNvPr>
@@ -1807,7 +1807,7 @@
     </p:spTree>
     <p:extLst>
       <p:ext uri="{BB962C8B-B14F-4D97-AF65-F5344CB8AC3E}">
-        <p14:creationId xmlns:p14="http://schemas.microsoft.com/office/powerpoint/2010/main" val="1799737044"/>
+        <p14:creationId xmlns:p14="http://schemas.microsoft.com/office/powerpoint/2010/main" val="2123356907"/>
       </p:ext>
     </p:extLst>
   </p:cSld>
@@ -1838,7 +1838,7 @@
           <p:cNvPr id="6" name="">
             <a:extLst xmlns:a="http://schemas.openxmlformats.org/drawingml/2006/main">
               <a:ext uri="{FF2B5EF4-FFF2-40B4-BE49-F238E27FC236}">
-                <a16:creationId xmlns:a16="http://schemas.microsoft.com/office/drawing/2014/main" id="{1C72B293-505F-4087-9290-7A4758C04D80}"/>
+                <a16:creationId xmlns:a16="http://schemas.microsoft.com/office/drawing/2014/main" id="{A58DACB9-E1C7-45D5-B316-C210F5E612D5}"/>
               </a:ext>
             </a:extLst>
           </p:cNvPr>
@@ -1895,7 +1895,7 @@
           <p:cNvPr id="2" name="">
             <a:extLst xmlns:a="http://schemas.openxmlformats.org/drawingml/2006/main">
               <a:ext uri="{FF2B5EF4-FFF2-40B4-BE49-F238E27FC236}">
-                <a16:creationId xmlns:a16="http://schemas.microsoft.com/office/drawing/2014/main" id="{3426853E-FFD1-44CB-809F-1FB6227DC4E7}"/>
+                <a16:creationId xmlns:a16="http://schemas.microsoft.com/office/drawing/2014/main" id="{D935D69F-1293-41C2-888B-85BAD766E2AE}"/>
               </a:ext>
             </a:extLst>
           </p:cNvPr>
@@ -1952,7 +1952,7 @@
           <p:cNvPr id="3" name="">
             <a:extLst xmlns:a="http://schemas.openxmlformats.org/drawingml/2006/main">
               <a:ext uri="{FF2B5EF4-FFF2-40B4-BE49-F238E27FC236}">
-                <a16:creationId xmlns:a16="http://schemas.microsoft.com/office/drawing/2014/main" id="{22EEB267-760E-43B4-B40F-8C564AE45F88}"/>
+                <a16:creationId xmlns:a16="http://schemas.microsoft.com/office/drawing/2014/main" id="{D6C9ABA0-C6A0-45DA-ADBE-0CA3E7877CAB}"/>
               </a:ext>
             </a:extLst>
           </p:cNvPr>
@@ -1963,7 +1963,7 @@
         </p:nvSpPr>
         <p:spPr>
           <a:xfrm xmlns:a="http://schemas.openxmlformats.org/drawingml/2006/main">
-            <a:off x="619125" y="2524125"/>
+            <a:off x="619125" y="2476500"/>
             <a:ext cx="10858500" cy="619125"/>
           </a:xfrm>
           <a:prstGeom xmlns:a="http://schemas.openxmlformats.org/drawingml/2006/main" prst="rect">
@@ -1999,7 +1999,7 @@
                 <a:ea typeface="Arial"/>
                 <a:cs typeface="Arial"/>
               </a:rPr>
-              <a:t>Ingest  →  Chunk  →  Embed &amp; index  →  Qdrant</a:t>
+              <a:t>Ingest  →  Chunk  →  Embed / index  →  Qdrant</a:t>
             </a:r>
           </a:p>
         </p:txBody>
@@ -2009,7 +2009,7 @@
           <p:cNvPr id="4" name="">
             <a:extLst xmlns:a="http://schemas.openxmlformats.org/drawingml/2006/main">
               <a:ext uri="{FF2B5EF4-FFF2-40B4-BE49-F238E27FC236}">
-                <a16:creationId xmlns:a16="http://schemas.microsoft.com/office/drawing/2014/main" id="{D3452218-7415-4E8A-80FD-9A0257C73C2B}"/>
+                <a16:creationId xmlns:a16="http://schemas.microsoft.com/office/drawing/2014/main" id="{231F14A1-83FC-49BB-912B-485EA29B8F0E}"/>
               </a:ext>
             </a:extLst>
           </p:cNvPr>
@@ -2020,7 +2020,7 @@
         </p:nvSpPr>
         <p:spPr>
           <a:xfrm xmlns:a="http://schemas.openxmlformats.org/drawingml/2006/main">
-            <a:off x="619125" y="3429000"/>
+            <a:off x="619125" y="3381375"/>
             <a:ext cx="10858500" cy="619125"/>
           </a:xfrm>
           <a:prstGeom xmlns:a="http://schemas.openxmlformats.org/drawingml/2006/main" prst="rect">
@@ -2038,25 +2038,25 @@
           <a:lstStyle xmlns:a="http://schemas.openxmlformats.org/drawingml/2006/main"/>
           <a:p xmlns:a="http://schemas.openxmlformats.org/drawingml/2006/main">
             <a:pPr>
-              <a:defRPr sz="2400" b="1">
-                <a:solidFill>
-                  <a:srgbClr val="202041"/>
-                </a:solidFill>
-                <a:latin typeface="Arial"/>
-                <a:ea typeface="Arial"/>
-                <a:cs typeface="Arial"/>
-              </a:defRPr>
-            </a:pPr>
-            <a:r>
-              <a:rPr sz="2400" b="1">
-                <a:solidFill>
-                  <a:srgbClr val="202041"/>
-                </a:solidFill>
-                <a:latin typeface="Arial"/>
-                <a:ea typeface="Arial"/>
-                <a:cs typeface="Arial"/>
-              </a:rPr>
-              <a:t>Web gateway  →  FastAPI  →  Filtered rubric retrieval</a:t>
+              <a:defRPr sz="2550" b="1">
+                <a:solidFill>
+                  <a:srgbClr val="202041"/>
+                </a:solidFill>
+                <a:latin typeface="Arial"/>
+                <a:ea typeface="Arial"/>
+                <a:cs typeface="Arial"/>
+              </a:defRPr>
+            </a:pPr>
+            <a:r>
+              <a:rPr sz="2550" b="1">
+                <a:solidFill>
+                  <a:srgbClr val="202041"/>
+                </a:solidFill>
+                <a:latin typeface="Arial"/>
+                <a:ea typeface="Arial"/>
+                <a:cs typeface="Arial"/>
+              </a:rPr>
+              <a:t>Web  →  FastAPI  →  Official context  →  Gemini</a:t>
             </a:r>
           </a:p>
         </p:txBody>
@@ -2066,7 +2066,7 @@
           <p:cNvPr id="5" name="">
             <a:extLst xmlns:a="http://schemas.openxmlformats.org/drawingml/2006/main">
               <a:ext uri="{FF2B5EF4-FFF2-40B4-BE49-F238E27FC236}">
-                <a16:creationId xmlns:a16="http://schemas.microsoft.com/office/drawing/2014/main" id="{88372319-4AC1-4884-84B9-ABA5F6218AD5}"/>
+                <a16:creationId xmlns:a16="http://schemas.microsoft.com/office/drawing/2014/main" id="{95E38800-5502-420D-9F56-8B400066234F}"/>
               </a:ext>
             </a:extLst>
           </p:cNvPr>
@@ -2113,7 +2113,7 @@
                 <a:ea typeface="Arial"/>
                 <a:cs typeface="Arial"/>
               </a:rPr>
-              <a:t>Five Python containers with frozen uv environments.</a:t>
+              <a:t>Frozen uv environments and source hashes.</a:t>
             </a:r>
           </a:p>
           <a:p xmlns:a="http://schemas.openxmlformats.org/drawingml/2006/main">
@@ -2136,7 +2136,7 @@
                 <a:ea typeface="Arial"/>
                 <a:cs typeface="Arial"/>
               </a:rPr>
-              <a:t>Successful data stages gate application startup.</a:t>
+              <a:t>Startup gates and persistent vector storage.</a:t>
             </a:r>
           </a:p>
           <a:p xmlns:a="http://schemas.openxmlformats.org/drawingml/2006/main">
@@ -2159,7 +2159,7 @@
                 <a:ea typeface="Arial"/>
                 <a:cs typeface="Arial"/>
               </a:rPr>
-              <a:t>The vector database stays on the internal network.</a:t>
+              <a:t>Source IDs, criterion coverage and essay quotes checked.</a:t>
             </a:r>
           </a:p>
         </p:txBody>
@@ -2167,7 +2167,7 @@
     </p:spTree>
     <p:extLst>
       <p:ext uri="{BB962C8B-B14F-4D97-AF65-F5344CB8AC3E}">
-        <p14:creationId xmlns:p14="http://schemas.microsoft.com/office/powerpoint/2010/main" val="169983412"/>
+        <p14:creationId xmlns:p14="http://schemas.microsoft.com/office/powerpoint/2010/main" val="668590843"/>
       </p:ext>
     </p:extLst>
   </p:cSld>
@@ -2198,7 +2198,7 @@
           <p:cNvPr id="7" name="">
             <a:extLst xmlns:a="http://schemas.openxmlformats.org/drawingml/2006/main">
               <a:ext uri="{FF2B5EF4-FFF2-40B4-BE49-F238E27FC236}">
-                <a16:creationId xmlns:a16="http://schemas.microsoft.com/office/drawing/2014/main" id="{60C6A1E0-BDA5-42A0-A09E-BF038E2DD657}"/>
+                <a16:creationId xmlns:a16="http://schemas.microsoft.com/office/drawing/2014/main" id="{5809FDBD-5B33-4A57-9154-59C8B2348CEC}"/>
               </a:ext>
             </a:extLst>
           </p:cNvPr>
@@ -2245,7 +2245,7 @@
                 <a:ea typeface="Arial"/>
                 <a:cs typeface="Arial"/>
               </a:rPr>
-              <a:t>Data sources and quality</a:t>
+              <a:t>Official knowledge sources</a:t>
             </a:r>
           </a:p>
         </p:txBody>
@@ -2255,7 +2255,7 @@
           <p:cNvPr id="2" name="">
             <a:extLst xmlns:a="http://schemas.openxmlformats.org/drawingml/2006/main">
               <a:ext uri="{FF2B5EF4-FFF2-40B4-BE49-F238E27FC236}">
-                <a16:creationId xmlns:a16="http://schemas.microsoft.com/office/drawing/2014/main" id="{0A966216-1AB1-463C-B2E3-59ADD128C34F}"/>
+                <a16:creationId xmlns:a16="http://schemas.microsoft.com/office/drawing/2014/main" id="{431857FB-774F-47D3-B73A-53732E60132B}"/>
               </a:ext>
             </a:extLst>
           </p:cNvPr>
@@ -2267,7 +2267,7 @@
         <p:spPr>
           <a:xfrm xmlns:a="http://schemas.openxmlformats.org/drawingml/2006/main">
             <a:off x="619125" y="1476375"/>
-            <a:ext cx="3333750" cy="1143000"/>
+            <a:ext cx="4000500" cy="1143000"/>
           </a:xfrm>
           <a:prstGeom xmlns:a="http://schemas.openxmlformats.org/drawingml/2006/main" prst="rect">
             <a:avLst/>
@@ -2302,7 +2302,7 @@
                 <a:ea typeface="Arial"/>
                 <a:cs typeface="Arial"/>
               </a:rPr>
-              <a:t>24</a:t>
+              <a:t>131</a:t>
             </a:r>
           </a:p>
         </p:txBody>
@@ -2312,7 +2312,7 @@
           <p:cNvPr id="3" name="">
             <a:extLst xmlns:a="http://schemas.openxmlformats.org/drawingml/2006/main">
               <a:ext uri="{FF2B5EF4-FFF2-40B4-BE49-F238E27FC236}">
-                <a16:creationId xmlns:a16="http://schemas.microsoft.com/office/drawing/2014/main" id="{CF05B1BF-D13C-4106-9080-BDB8D0FDA3E4}"/>
+                <a16:creationId xmlns:a16="http://schemas.microsoft.com/office/drawing/2014/main" id="{499F8A31-53C3-4516-9C5B-F83C1E5E24A4}"/>
               </a:ext>
             </a:extLst>
           </p:cNvPr>
@@ -2324,143 +2324,6 @@
         <p:spPr>
           <a:xfrm xmlns:a="http://schemas.openxmlformats.org/drawingml/2006/main">
             <a:off x="619125" y="2762250"/>
-            <a:ext cx="4572000" cy="904875"/>
-          </a:xfrm>
-          <a:prstGeom xmlns:a="http://schemas.openxmlformats.org/drawingml/2006/main" prst="rect">
-            <a:avLst/>
-          </a:prstGeom>
-          <a:noFill xmlns:a="http://schemas.openxmlformats.org/drawingml/2006/main"/>
-          <a:ln xmlns:a="http://schemas.openxmlformats.org/drawingml/2006/main" w="0">
-            <a:noFill/>
-          </a:ln>
-        </p:spPr>
-        <p:txBody>
-          <a:bodyPr xmlns:a="http://schemas.openxmlformats.org/drawingml/2006/main">
-            <a:noAutofit/>
-          </a:bodyPr>
-          <a:lstStyle xmlns:a="http://schemas.openxmlformats.org/drawingml/2006/main"/>
-          <a:p xmlns:a="http://schemas.openxmlformats.org/drawingml/2006/main">
-            <a:pPr>
-              <a:defRPr sz="2175" b="0">
-                <a:solidFill>
-                  <a:srgbClr val="202041"/>
-                </a:solidFill>
-                <a:latin typeface="Arial"/>
-                <a:ea typeface="Arial"/>
-                <a:cs typeface="Arial"/>
-              </a:defRPr>
-            </a:pPr>
-            <a:r>
-              <a:rPr sz="2175" b="0">
-                <a:solidFill>
-                  <a:srgbClr val="202041"/>
-                </a:solidFill>
-                <a:latin typeface="Arial"/>
-                <a:ea typeface="Arial"/>
-                <a:cs typeface="Arial"/>
-              </a:rPr>
-              <a:t>official rubric cells</a:t>
-            </a:r>
-          </a:p>
-          <a:p xmlns:a="http://schemas.openxmlformats.org/drawingml/2006/main">
-            <a:pPr>
-              <a:defRPr sz="2175" b="0">
-                <a:solidFill>
-                  <a:srgbClr val="202041"/>
-                </a:solidFill>
-                <a:latin typeface="Arial"/>
-                <a:ea typeface="Arial"/>
-                <a:cs typeface="Arial"/>
-              </a:defRPr>
-            </a:pPr>
-            <a:r>
-              <a:rPr sz="2175" b="0">
-                <a:solidFill>
-                  <a:srgbClr val="202041"/>
-                </a:solidFill>
-                <a:latin typeface="Arial"/>
-                <a:ea typeface="Arial"/>
-                <a:cs typeface="Arial"/>
-              </a:rPr>
-              <a:t>4 criteria × bands 4–9</a:t>
-            </a:r>
-          </a:p>
-        </p:txBody>
-      </p:sp>
-      <p:sp>
-        <p:nvSpPr>
-          <p:cNvPr id="4" name="">
-            <a:extLst xmlns:a="http://schemas.openxmlformats.org/drawingml/2006/main">
-              <a:ext uri="{FF2B5EF4-FFF2-40B4-BE49-F238E27FC236}">
-                <a16:creationId xmlns:a16="http://schemas.microsoft.com/office/drawing/2014/main" id="{EDEDF5D5-7FB3-4AF0-A8BE-8DC1D8AA1237}"/>
-              </a:ext>
-            </a:extLst>
-          </p:cNvPr>
-          <p:cNvSpPr>
-            <a:spLocks xmlns:a="http://schemas.openxmlformats.org/drawingml/2006/main" noGrp="1"/>
-          </p:cNvSpPr>
-          <p:nvPr/>
-        </p:nvSpPr>
-        <p:spPr>
-          <a:xfrm xmlns:a="http://schemas.openxmlformats.org/drawingml/2006/main">
-            <a:off x="6477000" y="1476375"/>
-            <a:ext cx="4762500" cy="1143000"/>
-          </a:xfrm>
-          <a:prstGeom xmlns:a="http://schemas.openxmlformats.org/drawingml/2006/main" prst="rect">
-            <a:avLst/>
-          </a:prstGeom>
-          <a:noFill xmlns:a="http://schemas.openxmlformats.org/drawingml/2006/main"/>
-          <a:ln xmlns:a="http://schemas.openxmlformats.org/drawingml/2006/main" w="0">
-            <a:noFill/>
-          </a:ln>
-        </p:spPr>
-        <p:txBody>
-          <a:bodyPr xmlns:a="http://schemas.openxmlformats.org/drawingml/2006/main">
-            <a:noAutofit/>
-          </a:bodyPr>
-          <a:lstStyle xmlns:a="http://schemas.openxmlformats.org/drawingml/2006/main"/>
-          <a:p xmlns:a="http://schemas.openxmlformats.org/drawingml/2006/main">
-            <a:pPr>
-              <a:defRPr sz="6900" b="1">
-                <a:solidFill>
-                  <a:srgbClr val="6550DD"/>
-                </a:solidFill>
-                <a:latin typeface="Arial"/>
-                <a:ea typeface="Arial"/>
-                <a:cs typeface="Arial"/>
-              </a:defRPr>
-            </a:pPr>
-            <a:r>
-              <a:rPr sz="6900" b="1">
-                <a:solidFill>
-                  <a:srgbClr val="6550DD"/>
-                </a:solidFill>
-                <a:latin typeface="Arial"/>
-                <a:ea typeface="Arial"/>
-                <a:cs typeface="Arial"/>
-              </a:rPr>
-              <a:t>8049</a:t>
-            </a:r>
-          </a:p>
-        </p:txBody>
-      </p:sp>
-      <p:sp>
-        <p:nvSpPr>
-          <p:cNvPr id="5" name="">
-            <a:extLst xmlns:a="http://schemas.openxmlformats.org/drawingml/2006/main">
-              <a:ext uri="{FF2B5EF4-FFF2-40B4-BE49-F238E27FC236}">
-                <a16:creationId xmlns:a16="http://schemas.microsoft.com/office/drawing/2014/main" id="{05A0861E-8003-4499-B459-98F475CF8130}"/>
-              </a:ext>
-            </a:extLst>
-          </p:cNvPr>
-          <p:cNvSpPr>
-            <a:spLocks xmlns:a="http://schemas.openxmlformats.org/drawingml/2006/main" noGrp="1"/>
-          </p:cNvSpPr>
-          <p:nvPr/>
-        </p:nvSpPr>
-        <p:spPr>
-          <a:xfrm xmlns:a="http://schemas.openxmlformats.org/drawingml/2006/main">
-            <a:off x="6477000" y="2762250"/>
             <a:ext cx="4762500" cy="904875"/>
           </a:xfrm>
           <a:prstGeom xmlns:a="http://schemas.openxmlformats.org/drawingml/2006/main" prst="rect">
@@ -2496,7 +2359,7 @@
                 <a:ea typeface="Arial"/>
                 <a:cs typeface="Arial"/>
               </a:rPr>
-              <a:t>candidate essays ingested</a:t>
+              <a:t>official source chunks</a:t>
             </a:r>
           </a:p>
           <a:p xmlns:a="http://schemas.openxmlformats.org/drawingml/2006/main">
@@ -2519,7 +2382,144 @@
                 <a:ea typeface="Arial"/>
                 <a:cs typeface="Arial"/>
               </a:rPr>
-              <a:t>8049 valid unique records</a:t>
+              <a:t>including every band 0–9</a:t>
+            </a:r>
+          </a:p>
+        </p:txBody>
+      </p:sp>
+      <p:sp>
+        <p:nvSpPr>
+          <p:cNvPr id="4" name="">
+            <a:extLst xmlns:a="http://schemas.openxmlformats.org/drawingml/2006/main">
+              <a:ext uri="{FF2B5EF4-FFF2-40B4-BE49-F238E27FC236}">
+                <a16:creationId xmlns:a16="http://schemas.microsoft.com/office/drawing/2014/main" id="{4E97734C-B2F3-4029-937B-D5602D067EBC}"/>
+              </a:ext>
+            </a:extLst>
+          </p:cNvPr>
+          <p:cNvSpPr>
+            <a:spLocks xmlns:a="http://schemas.openxmlformats.org/drawingml/2006/main" noGrp="1"/>
+          </p:cNvSpPr>
+          <p:nvPr/>
+        </p:nvSpPr>
+        <p:spPr>
+          <a:xfrm xmlns:a="http://schemas.openxmlformats.org/drawingml/2006/main">
+            <a:off x="6667500" y="1476375"/>
+            <a:ext cx="4000500" cy="1143000"/>
+          </a:xfrm>
+          <a:prstGeom xmlns:a="http://schemas.openxmlformats.org/drawingml/2006/main" prst="rect">
+            <a:avLst/>
+          </a:prstGeom>
+          <a:noFill xmlns:a="http://schemas.openxmlformats.org/drawingml/2006/main"/>
+          <a:ln xmlns:a="http://schemas.openxmlformats.org/drawingml/2006/main" w="0">
+            <a:noFill/>
+          </a:ln>
+        </p:spPr>
+        <p:txBody>
+          <a:bodyPr xmlns:a="http://schemas.openxmlformats.org/drawingml/2006/main">
+            <a:noAutofit/>
+          </a:bodyPr>
+          <a:lstStyle xmlns:a="http://schemas.openxmlformats.org/drawingml/2006/main"/>
+          <a:p xmlns:a="http://schemas.openxmlformats.org/drawingml/2006/main">
+            <a:pPr>
+              <a:defRPr sz="6900" b="1">
+                <a:solidFill>
+                  <a:srgbClr val="6550DD"/>
+                </a:solidFill>
+                <a:latin typeface="Arial"/>
+                <a:ea typeface="Arial"/>
+                <a:cs typeface="Arial"/>
+              </a:defRPr>
+            </a:pPr>
+            <a:r>
+              <a:rPr sz="6900" b="1">
+                <a:solidFill>
+                  <a:srgbClr val="6550DD"/>
+                </a:solidFill>
+                <a:latin typeface="Arial"/>
+                <a:ea typeface="Arial"/>
+                <a:cs typeface="Arial"/>
+              </a:rPr>
+              <a:t>20</a:t>
+            </a:r>
+          </a:p>
+        </p:txBody>
+      </p:sp>
+      <p:sp>
+        <p:nvSpPr>
+          <p:cNvPr id="5" name="">
+            <a:extLst xmlns:a="http://schemas.openxmlformats.org/drawingml/2006/main">
+              <a:ext uri="{FF2B5EF4-FFF2-40B4-BE49-F238E27FC236}">
+                <a16:creationId xmlns:a16="http://schemas.microsoft.com/office/drawing/2014/main" id="{CBDBE51F-3A5E-4AB3-A795-AABF06C16C66}"/>
+              </a:ext>
+            </a:extLst>
+          </p:cNvPr>
+          <p:cNvSpPr>
+            <a:spLocks xmlns:a="http://schemas.openxmlformats.org/drawingml/2006/main" noGrp="1"/>
+          </p:cNvSpPr>
+          <p:nvPr/>
+        </p:nvSpPr>
+        <p:spPr>
+          <a:xfrm xmlns:a="http://schemas.openxmlformats.org/drawingml/2006/main">
+            <a:off x="6667500" y="2762250"/>
+            <a:ext cx="4762500" cy="904875"/>
+          </a:xfrm>
+          <a:prstGeom xmlns:a="http://schemas.openxmlformats.org/drawingml/2006/main" prst="rect">
+            <a:avLst/>
+          </a:prstGeom>
+          <a:noFill xmlns:a="http://schemas.openxmlformats.org/drawingml/2006/main"/>
+          <a:ln xmlns:a="http://schemas.openxmlformats.org/drawingml/2006/main" w="0">
+            <a:noFill/>
+          </a:ln>
+        </p:spPr>
+        <p:txBody>
+          <a:bodyPr xmlns:a="http://schemas.openxmlformats.org/drawingml/2006/main">
+            <a:noAutofit/>
+          </a:bodyPr>
+          <a:lstStyle xmlns:a="http://schemas.openxmlformats.org/drawingml/2006/main"/>
+          <a:p xmlns:a="http://schemas.openxmlformats.org/drawingml/2006/main">
+            <a:pPr>
+              <a:defRPr sz="2175" b="0">
+                <a:solidFill>
+                  <a:srgbClr val="202041"/>
+                </a:solidFill>
+                <a:latin typeface="Arial"/>
+                <a:ea typeface="Arial"/>
+                <a:cs typeface="Arial"/>
+              </a:defRPr>
+            </a:pPr>
+            <a:r>
+              <a:rPr sz="2175" b="0">
+                <a:solidFill>
+                  <a:srgbClr val="202041"/>
+                </a:solidFill>
+                <a:latin typeface="Arial"/>
+                <a:ea typeface="Arial"/>
+                <a:cs typeface="Arial"/>
+              </a:rPr>
+              <a:t>detailed official checks</a:t>
+            </a:r>
+          </a:p>
+          <a:p xmlns:a="http://schemas.openxmlformats.org/drawingml/2006/main">
+            <a:pPr>
+              <a:defRPr sz="2175" b="0">
+                <a:solidFill>
+                  <a:srgbClr val="202041"/>
+                </a:solidFill>
+                <a:latin typeface="Arial"/>
+                <a:ea typeface="Arial"/>
+                <a:cs typeface="Arial"/>
+              </a:defRPr>
+            </a:pPr>
+            <a:r>
+              <a:rPr sz="2175" b="0">
+                <a:solidFill>
+                  <a:srgbClr val="202041"/>
+                </a:solidFill>
+                <a:latin typeface="Arial"/>
+                <a:ea typeface="Arial"/>
+                <a:cs typeface="Arial"/>
+              </a:rPr>
+              <a:t>TR 5 · CC 5 · LR 6 · GRA 4</a:t>
             </a:r>
           </a:p>
         </p:txBody>
@@ -2529,7 +2529,7 @@
           <p:cNvPr id="6" name="">
             <a:extLst xmlns:a="http://schemas.openxmlformats.org/drawingml/2006/main">
               <a:ext uri="{FF2B5EF4-FFF2-40B4-BE49-F238E27FC236}">
-                <a16:creationId xmlns:a16="http://schemas.microsoft.com/office/drawing/2014/main" id="{DB2D62E1-B05E-45BE-B88B-CE938B400816}"/>
+                <a16:creationId xmlns:a16="http://schemas.microsoft.com/office/drawing/2014/main" id="{6AFF7539-D64A-40B8-88FA-CBC4ABD873FD}"/>
               </a:ext>
             </a:extLst>
           </p:cNvPr>
@@ -2576,7 +2576,7 @@
                 <a:ea typeface="Arial"/>
                 <a:cs typeface="Arial"/>
               </a:rPr>
-              <a:t>Pinned source revisions and SHA-256 checks.</a:t>
+              <a:t>Complete band PDF + key criteria + British Council guidance.</a:t>
             </a:r>
           </a:p>
           <a:p xmlns:a="http://schemas.openxmlformats.org/drawingml/2006/main">
@@ -2599,7 +2599,7 @@
                 <a:ea typeface="Arial"/>
                 <a:cs typeface="Arial"/>
               </a:rPr>
-              <a:t>Exact-duplicate checks; normalized prompts remain in one split.</a:t>
+              <a:t>Task 2 / shared rules only during assessment.</a:t>
             </a:r>
           </a:p>
           <a:p xmlns:a="http://schemas.openxmlformats.org/drawingml/2006/main">
@@ -2622,7 +2622,7 @@
                 <a:ea typeface="Arial"/>
                 <a:cs typeface="Arial"/>
               </a:rPr>
-              <a:t>Official knowledge and adaptation candidates are separate.</a:t>
+              <a:t>8,049 candidate essays reserved for MS3; zero loaded now.</a:t>
             </a:r>
           </a:p>
         </p:txBody>
@@ -2630,7 +2630,7 @@
     </p:spTree>
     <p:extLst>
       <p:ext uri="{BB962C8B-B14F-4D97-AF65-F5344CB8AC3E}">
-        <p14:creationId xmlns:p14="http://schemas.microsoft.com/office/powerpoint/2010/main" val="288565728"/>
+        <p14:creationId xmlns:p14="http://schemas.microsoft.com/office/powerpoint/2010/main" val="1234548256"/>
       </p:ext>
     </p:extLst>
   </p:cSld>
@@ -2661,7 +2661,7 @@
           <p:cNvPr id="5" name="">
             <a:extLst xmlns:a="http://schemas.openxmlformats.org/drawingml/2006/main">
               <a:ext uri="{FF2B5EF4-FFF2-40B4-BE49-F238E27FC236}">
-                <a16:creationId xmlns:a16="http://schemas.microsoft.com/office/drawing/2014/main" id="{8BF1E751-6509-4020-83FE-B6CE7A1123D8}"/>
+                <a16:creationId xmlns:a16="http://schemas.microsoft.com/office/drawing/2014/main" id="{6A54F618-071C-44B4-8784-43089205E76D}"/>
               </a:ext>
             </a:extLst>
           </p:cNvPr>
@@ -2708,7 +2708,7 @@
                 <a:ea typeface="Arial"/>
                 <a:cs typeface="Arial"/>
               </a:rPr>
-              <a:t>Retrieval evidence</a:t>
+              <a:t>Retrieval and scoring context</a:t>
             </a:r>
           </a:p>
         </p:txBody>
@@ -2718,7 +2718,7 @@
           <p:cNvPr id="2" name="">
             <a:extLst xmlns:a="http://schemas.openxmlformats.org/drawingml/2006/main">
               <a:ext uri="{FF2B5EF4-FFF2-40B4-BE49-F238E27FC236}">
-                <a16:creationId xmlns:a16="http://schemas.microsoft.com/office/drawing/2014/main" id="{BF4C5255-4848-430C-9C4B-526E70C93562}"/>
+                <a16:creationId xmlns:a16="http://schemas.microsoft.com/office/drawing/2014/main" id="{010D690D-DE2C-46D6-81A7-D0FDBA57228A}"/>
               </a:ext>
             </a:extLst>
           </p:cNvPr>
@@ -2729,7 +2729,7 @@
         </p:nvSpPr>
         <p:spPr>
           <a:xfrm xmlns:a="http://schemas.openxmlformats.org/drawingml/2006/main">
-            <a:off x="619125" y="1524000"/>
+            <a:off x="619125" y="1476375"/>
             <a:ext cx="10858500" cy="952500"/>
           </a:xfrm>
           <a:prstGeom xmlns:a="http://schemas.openxmlformats.org/drawingml/2006/main" prst="rect">
@@ -2798,7 +2798,7 @@
           <p:cNvPr id="3" name="">
             <a:extLst xmlns:a="http://schemas.openxmlformats.org/drawingml/2006/main">
               <a:ext uri="{FF2B5EF4-FFF2-40B4-BE49-F238E27FC236}">
-                <a16:creationId xmlns:a16="http://schemas.microsoft.com/office/drawing/2014/main" id="{937D30E5-D7C1-4B8A-BDF5-E97472E7CD45}"/>
+                <a16:creationId xmlns:a16="http://schemas.microsoft.com/office/drawing/2014/main" id="{AE619DF0-D2BC-4B48-9EC2-F52E2CE1B2B0}"/>
               </a:ext>
             </a:extLst>
           </p:cNvPr>
@@ -2809,8 +2809,8 @@
         </p:nvSpPr>
         <p:spPr>
           <a:xfrm xmlns:a="http://schemas.openxmlformats.org/drawingml/2006/main">
-            <a:off x="619125" y="2952750"/>
-            <a:ext cx="10858500" cy="571500"/>
+            <a:off x="619125" y="2809875"/>
+            <a:ext cx="10858500" cy="619125"/>
           </a:xfrm>
           <a:prstGeom xmlns:a="http://schemas.openxmlformats.org/drawingml/2006/main" prst="rect">
             <a:avLst/>
@@ -2827,7 +2827,7 @@
           <a:lstStyle xmlns:a="http://schemas.openxmlformats.org/drawingml/2006/main"/>
           <a:p xmlns:a="http://schemas.openxmlformats.org/drawingml/2006/main">
             <a:pPr>
-              <a:defRPr sz="2250" b="0">
+              <a:defRPr sz="2400" b="1">
                 <a:solidFill>
                   <a:srgbClr val="6550DD"/>
                 </a:solidFill>
@@ -2837,7 +2837,7 @@
               </a:defRPr>
             </a:pPr>
             <a:r>
-              <a:rPr sz="2250" b="0">
+              <a:rPr sz="2400" b="1">
                 <a:solidFill>
                   <a:srgbClr val="6550DD"/>
                 </a:solidFill>
@@ -2845,7 +2845,7 @@
                 <a:ea typeface="Arial"/>
                 <a:cs typeface="Arial"/>
               </a:rPr>
-              <a:t>Academic essay  ·  Task Response  ·  Target 6.5</a:t>
+              <a:t>Task Response  ·  Target 6.5  →  Bands 6 and 7</a:t>
             </a:r>
           </a:p>
         </p:txBody>
@@ -2855,7 +2855,7 @@
           <p:cNvPr id="4" name="">
             <a:extLst xmlns:a="http://schemas.openxmlformats.org/drawingml/2006/main">
               <a:ext uri="{FF2B5EF4-FFF2-40B4-BE49-F238E27FC236}">
-                <a16:creationId xmlns:a16="http://schemas.microsoft.com/office/drawing/2014/main" id="{731CC7AA-30BC-487D-8C91-2FE40CC65D1A}"/>
+                <a16:creationId xmlns:a16="http://schemas.microsoft.com/office/drawing/2014/main" id="{6FBEDA08-7343-47B4-A808-C02CB7B01AB5}"/>
               </a:ext>
             </a:extLst>
           </p:cNvPr>
@@ -2866,8 +2866,8 @@
         </p:nvSpPr>
         <p:spPr>
           <a:xfrm xmlns:a="http://schemas.openxmlformats.org/drawingml/2006/main">
-            <a:off x="619125" y="3952875"/>
-            <a:ext cx="10858500" cy="1524000"/>
+            <a:off x="619125" y="4000500"/>
+            <a:ext cx="10858500" cy="1476375"/>
           </a:xfrm>
           <a:prstGeom xmlns:a="http://schemas.openxmlformats.org/drawingml/2006/main" prst="rect">
             <a:avLst/>
@@ -2902,7 +2902,7 @@
                 <a:ea typeface="Arial"/>
                 <a:cs typeface="Arial"/>
               </a:rPr>
-              <a:t>Result: official descriptors for bands 6 and 7.</a:t>
+              <a:t>Each match includes URL, page, band and stable chunk ID.</a:t>
             </a:r>
           </a:p>
           <a:p xmlns:a="http://schemas.openxmlformats.org/drawingml/2006/main">
@@ -2925,7 +2925,7 @@
                 <a:ea typeface="Arial"/>
                 <a:cs typeface="Arial"/>
               </a:rPr>
-              <a:t>Each match includes source URL, page, criterion, band and chunk ID.</a:t>
+              <a:t>Assessment retrieves the complete Task 2 band ladder.</a:t>
             </a:r>
           </a:p>
           <a:p xmlns:a="http://schemas.openxmlformats.org/drawingml/2006/main">
@@ -2948,7 +2948,7 @@
                 <a:ea typeface="Arial"/>
                 <a:cs typeface="Arial"/>
               </a:rPr>
-              <a:t>384-dimensional CPU embeddings; persistent Qdrant collection.</a:t>
+              <a:t>40 criterion-band cases verified; Task 1 excluded.</a:t>
             </a:r>
           </a:p>
         </p:txBody>
@@ -2956,7 +2956,7 @@
     </p:spTree>
     <p:extLst>
       <p:ext uri="{BB962C8B-B14F-4D97-AF65-F5344CB8AC3E}">
-        <p14:creationId xmlns:p14="http://schemas.microsoft.com/office/powerpoint/2010/main" val="785489515"/>
+        <p14:creationId xmlns:p14="http://schemas.microsoft.com/office/powerpoint/2010/main" val="1848010239"/>
       </p:ext>
     </p:extLst>
   </p:cSld>
@@ -2987,7 +2987,7 @@
           <p:cNvPr id="5" name="">
             <a:extLst xmlns:a="http://schemas.openxmlformats.org/drawingml/2006/main">
               <a:ext uri="{FF2B5EF4-FFF2-40B4-BE49-F238E27FC236}">
-                <a16:creationId xmlns:a16="http://schemas.microsoft.com/office/drawing/2014/main" id="{E25D2D46-E634-425E-B030-A110BE3B9D80}"/>
+                <a16:creationId xmlns:a16="http://schemas.microsoft.com/office/drawing/2014/main" id="{D0D29B18-5250-4599-A183-FECDD22DD1ED}"/>
               </a:ext>
             </a:extLst>
           </p:cNvPr>
@@ -3034,7 +3034,7 @@
                 <a:ea typeface="Arial"/>
                 <a:cs typeface="Arial"/>
               </a:rPr>
-              <a:t>Four-criterion feedback</a:t>
+              <a:t>Real criterion feedback</a:t>
             </a:r>
           </a:p>
         </p:txBody>
@@ -3048,13 +3048,13 @@
           <p:nvPr/>
         </p:nvPicPr>
         <p:blipFill>
-          <a:blip xmlns:r="http://schemas.openxmlformats.org/officeDocument/2006/relationships" xmlns:a="http://schemas.openxmlformats.org/drawingml/2006/main" r:embed="Rd25d0a7430944f8c"/>
+          <a:blip xmlns:r="http://schemas.openxmlformats.org/officeDocument/2006/relationships" xmlns:a="http://schemas.openxmlformats.org/drawingml/2006/main" r:embed="R7bf89c6eb6ed4ebc"/>
           <a:stretch xmlns:a="http://schemas.openxmlformats.org/drawingml/2006/main"/>
         </p:blipFill>
         <p:spPr>
           <a:xfrm xmlns:a="http://schemas.openxmlformats.org/drawingml/2006/main">
-            <a:off x="1076201" y="1333500"/>
-            <a:ext cx="4781797" cy="5000625"/>
+            <a:off x="951379" y="1333500"/>
+            <a:ext cx="5126691" cy="5000625"/>
           </a:xfrm>
           <a:prstGeom xmlns:a="http://schemas.openxmlformats.org/drawingml/2006/main" prst="rect">
             <a:avLst/>
@@ -3066,7 +3066,7 @@
           <p:cNvPr id="3" name="">
             <a:extLst xmlns:a="http://schemas.openxmlformats.org/drawingml/2006/main">
               <a:ext uri="{FF2B5EF4-FFF2-40B4-BE49-F238E27FC236}">
-                <a16:creationId xmlns:a16="http://schemas.microsoft.com/office/drawing/2014/main" id="{0086042C-E21E-4EED-974D-B5CDE822852C}"/>
+                <a16:creationId xmlns:a16="http://schemas.microsoft.com/office/drawing/2014/main" id="{4C8278F9-11F5-437F-9FFD-355FDC800DDE}"/>
               </a:ext>
             </a:extLst>
           </p:cNvPr>
@@ -3077,8 +3077,8 @@
         </p:nvSpPr>
         <p:spPr>
           <a:xfrm xmlns:a="http://schemas.openxmlformats.org/drawingml/2006/main">
-            <a:off x="6667500" y="1619250"/>
-            <a:ext cx="4762500" cy="3714750"/>
+            <a:off x="6810375" y="1619250"/>
+            <a:ext cx="4572000" cy="3714750"/>
           </a:xfrm>
           <a:prstGeom xmlns:a="http://schemas.openxmlformats.org/drawingml/2006/main" prst="rect">
             <a:avLst/>
@@ -3113,7 +3113,7 @@
                 <a:ea typeface="Arial"/>
                 <a:cs typeface="Arial"/>
               </a:rPr>
-              <a:t>Four criterion tabs</a:t>
+              <a:t>Four criterion scores</a:t>
             </a:r>
           </a:p>
           <a:p xmlns:a="http://schemas.openxmlformats.org/drawingml/2006/main">
@@ -3169,7 +3169,7 @@
                 <a:ea typeface="Arial"/>
                 <a:cs typeface="Arial"/>
               </a:rPr>
-              <a:t>Specific revision steps</a:t>
+              <a:t>Specific revision examples</a:t>
             </a:r>
           </a:p>
           <a:p xmlns:a="http://schemas.openxmlformats.org/drawingml/2006/main">
@@ -3197,7 +3197,7 @@
                 <a:ea typeface="Arial"/>
                 <a:cs typeface="Arial"/>
               </a:rPr>
-              <a:t>Official source context</a:t>
+              <a:t>20 official detailed checks</a:t>
             </a:r>
           </a:p>
         </p:txBody>
@@ -3207,7 +3207,7 @@
           <p:cNvPr id="4" name="">
             <a:extLst xmlns:a="http://schemas.openxmlformats.org/drawingml/2006/main">
               <a:ext uri="{FF2B5EF4-FFF2-40B4-BE49-F238E27FC236}">
-                <a16:creationId xmlns:a16="http://schemas.microsoft.com/office/drawing/2014/main" id="{1F436D4D-7DCC-48F5-9F38-424E351C439F}"/>
+                <a16:creationId xmlns:a16="http://schemas.microsoft.com/office/drawing/2014/main" id="{99517E9A-A2A5-4728-94E5-D9E0FEA0FC9C}"/>
               </a:ext>
             </a:extLst>
           </p:cNvPr>
@@ -3218,8 +3218,8 @@
         </p:nvSpPr>
         <p:spPr>
           <a:xfrm xmlns:a="http://schemas.openxmlformats.org/drawingml/2006/main">
-            <a:off x="6667500" y="5715000"/>
-            <a:ext cx="4762500" cy="457200"/>
+            <a:off x="6810375" y="5715000"/>
+            <a:ext cx="4667250" cy="457200"/>
           </a:xfrm>
           <a:prstGeom xmlns:a="http://schemas.openxmlformats.org/drawingml/2006/main" prst="rect">
             <a:avLst/>
@@ -3254,7 +3254,7 @@
                 <a:ea typeface="Arial"/>
                 <a:cs typeface="Arial"/>
               </a:rPr>
-              <a:t>MS2 templates · scoring follows in MS3</a:t>
+              <a:t>Source and page links in every criterion</a:t>
             </a:r>
           </a:p>
         </p:txBody>
@@ -3262,7 +3262,7 @@
     </p:spTree>
     <p:extLst>
       <p:ext uri="{BB962C8B-B14F-4D97-AF65-F5344CB8AC3E}">
-        <p14:creationId xmlns:p14="http://schemas.microsoft.com/office/powerpoint/2010/main" val="420563533"/>
+        <p14:creationId xmlns:p14="http://schemas.microsoft.com/office/powerpoint/2010/main" val="1816760471"/>
       </p:ext>
     </p:extLst>
   </p:cSld>
@@ -3293,7 +3293,7 @@
           <p:cNvPr id="5" name="">
             <a:extLst xmlns:a="http://schemas.openxmlformats.org/drawingml/2006/main">
               <a:ext uri="{FF2B5EF4-FFF2-40B4-BE49-F238E27FC236}">
-                <a16:creationId xmlns:a16="http://schemas.microsoft.com/office/drawing/2014/main" id="{DAFCF21E-03F5-4327-9758-BD7155E073E8}"/>
+                <a16:creationId xmlns:a16="http://schemas.microsoft.com/office/drawing/2014/main" id="{303906F5-32F3-4485-95D7-A4E45A344745}"/>
               </a:ext>
             </a:extLst>
           </p:cNvPr>
@@ -3340,7 +3340,7 @@
                 <a:ea typeface="Arial"/>
                 <a:cs typeface="Arial"/>
               </a:rPr>
-              <a:t>Requirements for the model essay</a:t>
+              <a:t>Model essay and separate assessment</a:t>
             </a:r>
           </a:p>
         </p:txBody>
@@ -3354,13 +3354,13 @@
           <p:nvPr/>
         </p:nvPicPr>
         <p:blipFill>
-          <a:blip xmlns:r="http://schemas.openxmlformats.org/officeDocument/2006/relationships" xmlns:a="http://schemas.openxmlformats.org/drawingml/2006/main" r:embed="R57b1c9599c2d460d"/>
+          <a:blip xmlns:r="http://schemas.openxmlformats.org/officeDocument/2006/relationships" xmlns:a="http://schemas.openxmlformats.org/drawingml/2006/main" r:embed="Ree83eebb6022407a"/>
           <a:stretch xmlns:a="http://schemas.openxmlformats.org/drawingml/2006/main"/>
         </p:blipFill>
         <p:spPr>
           <a:xfrm xmlns:a="http://schemas.openxmlformats.org/drawingml/2006/main">
-            <a:off x="1068426" y="1333500"/>
-            <a:ext cx="4797348" cy="5000625"/>
+            <a:off x="1389766" y="1333500"/>
+            <a:ext cx="6059668" cy="4857750"/>
           </a:xfrm>
           <a:prstGeom xmlns:a="http://schemas.openxmlformats.org/drawingml/2006/main" prst="rect">
             <a:avLst/>
@@ -3372,7 +3372,7 @@
           <p:cNvPr id="3" name="">
             <a:extLst xmlns:a="http://schemas.openxmlformats.org/drawingml/2006/main">
               <a:ext uri="{FF2B5EF4-FFF2-40B4-BE49-F238E27FC236}">
-                <a16:creationId xmlns:a16="http://schemas.microsoft.com/office/drawing/2014/main" id="{20A2934E-1920-4FCE-9758-56D27C01D21F}"/>
+                <a16:creationId xmlns:a16="http://schemas.microsoft.com/office/drawing/2014/main" id="{AB570316-E652-46F2-B1D8-72F3B0A1EC2A}"/>
               </a:ext>
             </a:extLst>
           </p:cNvPr>
@@ -3383,8 +3383,8 @@
         </p:nvSpPr>
         <p:spPr>
           <a:xfrm xmlns:a="http://schemas.openxmlformats.org/drawingml/2006/main">
-            <a:off x="6667500" y="1619250"/>
-            <a:ext cx="4762500" cy="3714750"/>
+            <a:off x="8572500" y="1714500"/>
+            <a:ext cx="2857500" cy="1285875"/>
           </a:xfrm>
           <a:prstGeom xmlns:a="http://schemas.openxmlformats.org/drawingml/2006/main" prst="rect">
             <a:avLst/>
@@ -3401,109 +3401,48 @@
           <a:lstStyle xmlns:a="http://schemas.openxmlformats.org/drawingml/2006/main"/>
           <a:p xmlns:a="http://schemas.openxmlformats.org/drawingml/2006/main">
             <a:pPr>
-              <a:defRPr sz="2100" b="1">
-                <a:solidFill>
-                  <a:srgbClr val="202041"/>
-                </a:solidFill>
-                <a:latin typeface="Arial"/>
-                <a:ea typeface="Arial"/>
-                <a:cs typeface="Arial"/>
-              </a:defRPr>
-            </a:pPr>
-            <a:r>
-              <a:rPr sz="2100" b="1">
-                <a:solidFill>
-                  <a:srgbClr val="202041"/>
-                </a:solidFill>
-                <a:latin typeface="Arial"/>
-                <a:ea typeface="Arial"/>
-                <a:cs typeface="Arial"/>
-              </a:rPr>
-              <a:t>Target band</a:t>
-            </a:r>
-          </a:p>
-          <a:p xmlns:a="http://schemas.openxmlformats.org/drawingml/2006/main">
-            <a:r>
-              <a:t/>
-            </a:r>
-          </a:p>
-          <a:p xmlns:a="http://schemas.openxmlformats.org/drawingml/2006/main">
-            <a:pPr>
-              <a:defRPr sz="2100" b="1">
-                <a:solidFill>
-                  <a:srgbClr val="202041"/>
-                </a:solidFill>
-                <a:latin typeface="Arial"/>
-                <a:ea typeface="Arial"/>
-                <a:cs typeface="Arial"/>
-              </a:defRPr>
-            </a:pPr>
-            <a:r>
-              <a:rPr sz="2100" b="1">
-                <a:solidFill>
-                  <a:srgbClr val="202041"/>
-                </a:solidFill>
-                <a:latin typeface="Arial"/>
-                <a:ea typeface="Arial"/>
-                <a:cs typeface="Arial"/>
-              </a:rPr>
-              <a:t>Your position</a:t>
-            </a:r>
-          </a:p>
-          <a:p xmlns:a="http://schemas.openxmlformats.org/drawingml/2006/main">
-            <a:r>
-              <a:t/>
-            </a:r>
-          </a:p>
-          <a:p xmlns:a="http://schemas.openxmlformats.org/drawingml/2006/main">
-            <a:pPr>
-              <a:defRPr sz="2100" b="1">
-                <a:solidFill>
-                  <a:srgbClr val="202041"/>
-                </a:solidFill>
-                <a:latin typeface="Arial"/>
-                <a:ea typeface="Arial"/>
-                <a:cs typeface="Arial"/>
-              </a:defRPr>
-            </a:pPr>
-            <a:r>
-              <a:rPr sz="2100" b="1">
-                <a:solidFill>
-                  <a:srgbClr val="202041"/>
-                </a:solidFill>
-                <a:latin typeface="Arial"/>
-                <a:ea typeface="Arial"/>
-                <a:cs typeface="Arial"/>
-              </a:rPr>
-              <a:t>Ideas to preserve</a:t>
-            </a:r>
-          </a:p>
-          <a:p xmlns:a="http://schemas.openxmlformats.org/drawingml/2006/main">
-            <a:r>
-              <a:t/>
-            </a:r>
-          </a:p>
-          <a:p xmlns:a="http://schemas.openxmlformats.org/drawingml/2006/main">
-            <a:pPr>
-              <a:defRPr sz="2100" b="1">
-                <a:solidFill>
-                  <a:srgbClr val="202041"/>
-                </a:solidFill>
-                <a:latin typeface="Arial"/>
-                <a:ea typeface="Arial"/>
-                <a:cs typeface="Arial"/>
-              </a:defRPr>
-            </a:pPr>
-            <a:r>
-              <a:rPr sz="2100" b="1">
-                <a:solidFill>
-                  <a:srgbClr val="202041"/>
-                </a:solidFill>
-                <a:latin typeface="Arial"/>
-                <a:ea typeface="Arial"/>
-                <a:cs typeface="Arial"/>
-              </a:rPr>
-              <a:t>Live backend writing brief</a:t>
+              <a:defRPr sz="2550" b="1">
+                <a:solidFill>
+                  <a:srgbClr val="6550DD"/>
+                </a:solidFill>
+                <a:latin typeface="Arial"/>
+                <a:ea typeface="Arial"/>
+                <a:cs typeface="Arial"/>
+              </a:defRPr>
+            </a:pPr>
+            <a:r>
+              <a:rPr sz="2550" b="1">
+                <a:solidFill>
+                  <a:srgbClr val="6550DD"/>
+                </a:solidFill>
+                <a:latin typeface="Arial"/>
+                <a:ea typeface="Arial"/>
+                <a:cs typeface="Arial"/>
+              </a:rPr>
+              <a:t>Target 7.0</a:t>
+            </a:r>
+          </a:p>
+          <a:p xmlns:a="http://schemas.openxmlformats.org/drawingml/2006/main">
+            <a:pPr>
+              <a:defRPr sz="2550" b="1">
+                <a:solidFill>
+                  <a:srgbClr val="6550DD"/>
+                </a:solidFill>
+                <a:latin typeface="Arial"/>
+                <a:ea typeface="Arial"/>
+                <a:cs typeface="Arial"/>
+              </a:defRPr>
+            </a:pPr>
+            <a:r>
+              <a:rPr sz="2550" b="1">
+                <a:solidFill>
+                  <a:srgbClr val="6550DD"/>
+                </a:solidFill>
+                <a:latin typeface="Arial"/>
+                <a:ea typeface="Arial"/>
+                <a:cs typeface="Arial"/>
+              </a:rPr>
+              <a:t>Assessed 9.0</a:t>
             </a:r>
           </a:p>
         </p:txBody>
@@ -3513,7 +3452,7 @@
           <p:cNvPr id="4" name="">
             <a:extLst xmlns:a="http://schemas.openxmlformats.org/drawingml/2006/main">
               <a:ext uri="{FF2B5EF4-FFF2-40B4-BE49-F238E27FC236}">
-                <a16:creationId xmlns:a16="http://schemas.microsoft.com/office/drawing/2014/main" id="{FE3AEF60-146B-44B8-B79A-4CFC72BC0C90}"/>
+                <a16:creationId xmlns:a16="http://schemas.microsoft.com/office/drawing/2014/main" id="{C215AB35-F31E-4547-A563-74D3E0ACDD5F}"/>
               </a:ext>
             </a:extLst>
           </p:cNvPr>
@@ -3524,8 +3463,8 @@
         </p:nvSpPr>
         <p:spPr>
           <a:xfrm xmlns:a="http://schemas.openxmlformats.org/drawingml/2006/main">
-            <a:off x="6667500" y="5715000"/>
-            <a:ext cx="4762500" cy="457200"/>
+            <a:off x="8572500" y="3333750"/>
+            <a:ext cx="2857500" cy="2571750"/>
           </a:xfrm>
           <a:prstGeom xmlns:a="http://schemas.openxmlformats.org/drawingml/2006/main" prst="rect">
             <a:avLst/>
@@ -3542,25 +3481,109 @@
           <a:lstStyle xmlns:a="http://schemas.openxmlformats.org/drawingml/2006/main"/>
           <a:p xmlns:a="http://schemas.openxmlformats.org/drawingml/2006/main">
             <a:pPr>
-              <a:defRPr sz="1725" b="0">
-                <a:solidFill>
-                  <a:srgbClr val="6550DD"/>
-                </a:solidFill>
-                <a:latin typeface="Arial"/>
-                <a:ea typeface="Arial"/>
-                <a:cs typeface="Arial"/>
-              </a:defRPr>
-            </a:pPr>
-            <a:r>
-              <a:rPr sz="1725" b="0">
-                <a:solidFill>
-                  <a:srgbClr val="6550DD"/>
-                </a:solidFill>
-                <a:latin typeface="Arial"/>
-                <a:ea typeface="Arial"/>
-                <a:cs typeface="Arial"/>
-              </a:rPr>
-              <a:t>Generation follows in MS3</a:t>
+              <a:defRPr sz="1800" b="1">
+                <a:solidFill>
+                  <a:srgbClr val="202041"/>
+                </a:solidFill>
+                <a:latin typeface="Arial"/>
+                <a:ea typeface="Arial"/>
+                <a:cs typeface="Arial"/>
+              </a:defRPr>
+            </a:pPr>
+            <a:r>
+              <a:rPr sz="1800" b="1">
+                <a:solidFill>
+                  <a:srgbClr val="202041"/>
+                </a:solidFill>
+                <a:latin typeface="Arial"/>
+                <a:ea typeface="Arial"/>
+                <a:cs typeface="Arial"/>
+              </a:rPr>
+              <a:t>Full prose</a:t>
+            </a:r>
+          </a:p>
+          <a:p xmlns:a="http://schemas.openxmlformats.org/drawingml/2006/main">
+            <a:r>
+              <a:t/>
+            </a:r>
+          </a:p>
+          <a:p xmlns:a="http://schemas.openxmlformats.org/drawingml/2006/main">
+            <a:pPr>
+              <a:defRPr sz="1800" b="1">
+                <a:solidFill>
+                  <a:srgbClr val="202041"/>
+                </a:solidFill>
+                <a:latin typeface="Arial"/>
+                <a:ea typeface="Arial"/>
+                <a:cs typeface="Arial"/>
+              </a:defRPr>
+            </a:pPr>
+            <a:r>
+              <a:rPr sz="1800" b="1">
+                <a:solidFill>
+                  <a:srgbClr val="202041"/>
+                </a:solidFill>
+                <a:latin typeface="Arial"/>
+                <a:ea typeface="Arial"/>
+                <a:cs typeface="Arial"/>
+              </a:rPr>
+              <a:t>Your position and ideas</a:t>
+            </a:r>
+          </a:p>
+          <a:p xmlns:a="http://schemas.openxmlformats.org/drawingml/2006/main">
+            <a:r>
+              <a:t/>
+            </a:r>
+          </a:p>
+          <a:p xmlns:a="http://schemas.openxmlformats.org/drawingml/2006/main">
+            <a:pPr>
+              <a:defRPr sz="1800" b="1">
+                <a:solidFill>
+                  <a:srgbClr val="202041"/>
+                </a:solidFill>
+                <a:latin typeface="Arial"/>
+                <a:ea typeface="Arial"/>
+                <a:cs typeface="Arial"/>
+              </a:defRPr>
+            </a:pPr>
+            <a:r>
+              <a:rPr sz="1800" b="1">
+                <a:solidFill>
+                  <a:srgbClr val="202041"/>
+                </a:solidFill>
+                <a:latin typeface="Arial"/>
+                <a:ea typeface="Arial"/>
+                <a:cs typeface="Arial"/>
+              </a:rPr>
+              <a:t>Fresh assessment</a:t>
+            </a:r>
+          </a:p>
+          <a:p xmlns:a="http://schemas.openxmlformats.org/drawingml/2006/main">
+            <a:r>
+              <a:t/>
+            </a:r>
+          </a:p>
+          <a:p xmlns:a="http://schemas.openxmlformats.org/drawingml/2006/main">
+            <a:pPr>
+              <a:defRPr sz="1800" b="1">
+                <a:solidFill>
+                  <a:srgbClr val="202041"/>
+                </a:solidFill>
+                <a:latin typeface="Arial"/>
+                <a:ea typeface="Arial"/>
+                <a:cs typeface="Arial"/>
+              </a:defRPr>
+            </a:pPr>
+            <a:r>
+              <a:rPr sz="1800" b="1">
+                <a:solidFill>
+                  <a:srgbClr val="202041"/>
+                </a:solidFill>
+                <a:latin typeface="Arial"/>
+                <a:ea typeface="Arial"/>
+                <a:cs typeface="Arial"/>
+              </a:rPr>
+              <a:t>Explained criterion scores</a:t>
             </a:r>
           </a:p>
         </p:txBody>
@@ -3568,7 +3591,7 @@
     </p:spTree>
     <p:extLst>
       <p:ext uri="{BB962C8B-B14F-4D97-AF65-F5344CB8AC3E}">
-        <p14:creationId xmlns:p14="http://schemas.microsoft.com/office/powerpoint/2010/main" val="1006891799"/>
+        <p14:creationId xmlns:p14="http://schemas.microsoft.com/office/powerpoint/2010/main" val="1657478592"/>
       </p:ext>
     </p:extLst>
   </p:cSld>
@@ -3596,10 +3619,10 @@
       </p:grpSpPr>
       <p:sp>
         <p:nvSpPr>
-          <p:cNvPr id="4" name="">
+          <p:cNvPr id="5" name="">
             <a:extLst xmlns:a="http://schemas.openxmlformats.org/drawingml/2006/main">
               <a:ext uri="{FF2B5EF4-FFF2-40B4-BE49-F238E27FC236}">
-                <a16:creationId xmlns:a16="http://schemas.microsoft.com/office/drawing/2014/main" id="{E4E9D302-9FB4-4649-BDE5-EDAFECBDAF8E}"/>
+                <a16:creationId xmlns:a16="http://schemas.microsoft.com/office/drawing/2014/main" id="{56BF8322-1E53-4D86-8E1F-A69BA6F71D29}"/>
               </a:ext>
             </a:extLst>
           </p:cNvPr>
@@ -3646,27 +3669,27 @@
                 <a:ea typeface="Arial"/>
                 <a:cs typeface="Arial"/>
               </a:rPr>
-              <a:t>Running environment and checks</a:t>
+              <a:t>Verified cloud run</a:t>
             </a:r>
           </a:p>
         </p:txBody>
       </p:sp>
       <p:pic>
         <p:nvPicPr>
-          <p:cNvPr id="5" name=""/>
+          <p:cNvPr id="6" name=""/>
           <p:cNvPicPr>
             <a:picLocks xmlns:a="http://schemas.openxmlformats.org/drawingml/2006/main" noChangeAspect="1"/>
           </p:cNvPicPr>
           <p:nvPr/>
         </p:nvPicPr>
         <p:blipFill>
-          <a:blip xmlns:r="http://schemas.openxmlformats.org/officeDocument/2006/relationships" xmlns:a="http://schemas.openxmlformats.org/drawingml/2006/main" r:embed="R27e2feda68bf4ea5"/>
+          <a:blip xmlns:r="http://schemas.openxmlformats.org/officeDocument/2006/relationships" xmlns:a="http://schemas.openxmlformats.org/drawingml/2006/main" r:embed="Rd5000a5a39424a13"/>
           <a:stretch xmlns:a="http://schemas.openxmlformats.org/drawingml/2006/main"/>
         </p:blipFill>
         <p:spPr>
           <a:xfrm xmlns:a="http://schemas.openxmlformats.org/drawingml/2006/main">
-            <a:off x="609600" y="1758661"/>
-            <a:ext cx="7239000" cy="3816927"/>
+            <a:off x="609600" y="1731065"/>
+            <a:ext cx="7239000" cy="3776870"/>
           </a:xfrm>
           <a:prstGeom xmlns:a="http://schemas.openxmlformats.org/drawingml/2006/main" prst="rect">
             <a:avLst/>
@@ -3678,7 +3701,7 @@
           <p:cNvPr id="3" name="">
             <a:extLst xmlns:a="http://schemas.openxmlformats.org/drawingml/2006/main">
               <a:ext uri="{FF2B5EF4-FFF2-40B4-BE49-F238E27FC236}">
-                <a16:creationId xmlns:a16="http://schemas.microsoft.com/office/drawing/2014/main" id="{75DAD895-6DAD-4F58-BDC9-24C76B3CE424}"/>
+                <a16:creationId xmlns:a16="http://schemas.microsoft.com/office/drawing/2014/main" id="{5C6CC7CD-54AB-4D78-A5FB-BBABE5EC6E60}"/>
               </a:ext>
             </a:extLst>
           </p:cNvPr>
@@ -3689,8 +3712,8 @@
         </p:nvSpPr>
         <p:spPr>
           <a:xfrm xmlns:a="http://schemas.openxmlformats.org/drawingml/2006/main">
-            <a:off x="8191500" y="1619250"/>
-            <a:ext cx="3333750" cy="4000500"/>
+            <a:off x="8334375" y="1571625"/>
+            <a:ext cx="3238500" cy="3714750"/>
           </a:xfrm>
           <a:prstGeom xmlns:a="http://schemas.openxmlformats.org/drawingml/2006/main" prst="rect">
             <a:avLst/>
@@ -3707,7 +3730,7 @@
           <a:lstStyle xmlns:a="http://schemas.openxmlformats.org/drawingml/2006/main"/>
           <a:p xmlns:a="http://schemas.openxmlformats.org/drawingml/2006/main">
             <a:pPr>
-              <a:defRPr sz="2100" b="1">
+              <a:defRPr sz="2175" b="1">
                 <a:solidFill>
                   <a:srgbClr val="6550DD"/>
                 </a:solidFill>
@@ -3717,7 +3740,7 @@
               </a:defRPr>
             </a:pPr>
             <a:r>
-              <a:rPr sz="2100" b="1">
+              <a:rPr sz="2175" b="1">
                 <a:solidFill>
                   <a:srgbClr val="6550DD"/>
                 </a:solidFill>
@@ -3725,7 +3748,7 @@
                 <a:ea typeface="Arial"/>
                 <a:cs typeface="Arial"/>
               </a:rPr>
-              <a:t>9 unit tests passed</a:t>
+              <a:t>18 local tests</a:t>
             </a:r>
           </a:p>
           <a:p xmlns:a="http://schemas.openxmlformats.org/drawingml/2006/main">
@@ -3735,7 +3758,7 @@
           </a:p>
           <a:p xmlns:a="http://schemas.openxmlformats.org/drawingml/2006/main">
             <a:pPr>
-              <a:defRPr sz="2100" b="1">
+              <a:defRPr sz="2175" b="1">
                 <a:solidFill>
                   <a:srgbClr val="6550DD"/>
                 </a:solidFill>
@@ -3745,7 +3768,7 @@
               </a:defRPr>
             </a:pPr>
             <a:r>
-              <a:rPr sz="2100" b="1">
+              <a:rPr sz="2175" b="1">
                 <a:solidFill>
                   <a:srgbClr val="6550DD"/>
                 </a:solidFill>
@@ -3753,7 +3776,7 @@
                 <a:ea typeface="Arial"/>
                 <a:cs typeface="Arial"/>
               </a:rPr>
-              <a:t>8 live checks passed</a:t>
+              <a:t>12 workflow checks</a:t>
             </a:r>
           </a:p>
           <a:p xmlns:a="http://schemas.openxmlformats.org/drawingml/2006/main">
@@ -3763,7 +3786,7 @@
           </a:p>
           <a:p xmlns:a="http://schemas.openxmlformats.org/drawingml/2006/main">
             <a:pPr>
-              <a:defRPr sz="2100" b="1">
+              <a:defRPr sz="2175" b="1">
                 <a:solidFill>
                   <a:srgbClr val="6550DD"/>
                 </a:solidFill>
@@ -3773,7 +3796,7 @@
               </a:defRPr>
             </a:pPr>
             <a:r>
-              <a:rPr sz="2100" b="1">
+              <a:rPr sz="2175" b="1">
                 <a:solidFill>
                   <a:srgbClr val="6550DD"/>
                 </a:solidFill>
@@ -3781,7 +3804,7 @@
                 <a:ea typeface="Arial"/>
                 <a:cs typeface="Arial"/>
               </a:rPr>
-              <a:t>Source hashes verified</a:t>
+              <a:t>40 retrieval cases</a:t>
             </a:r>
           </a:p>
           <a:p xmlns:a="http://schemas.openxmlformats.org/drawingml/2006/main">
@@ -3791,7 +3814,7 @@
           </a:p>
           <a:p xmlns:a="http://schemas.openxmlformats.org/drawingml/2006/main">
             <a:pPr>
-              <a:defRPr sz="2100" b="1">
+              <a:defRPr sz="2175" b="1">
                 <a:solidFill>
                   <a:srgbClr val="6550DD"/>
                 </a:solidFill>
@@ -3801,7 +3824,7 @@
               </a:defRPr>
             </a:pPr>
             <a:r>
-              <a:rPr sz="2100" b="1">
+              <a:rPr sz="2175" b="1">
                 <a:solidFill>
                   <a:srgbClr val="6550DD"/>
                 </a:solidFill>
@@ -3809,7 +3832,64 @@
                 <a:ea typeface="Arial"/>
                 <a:cs typeface="Arial"/>
               </a:rPr>
-              <a:t>One-command rerun</a:t>
+              <a:t>131 indexed points</a:t>
+            </a:r>
+          </a:p>
+        </p:txBody>
+      </p:sp>
+      <p:sp>
+        <p:nvSpPr>
+          <p:cNvPr id="4" name="">
+            <a:extLst xmlns:a="http://schemas.openxmlformats.org/drawingml/2006/main">
+              <a:ext uri="{FF2B5EF4-FFF2-40B4-BE49-F238E27FC236}">
+                <a16:creationId xmlns:a16="http://schemas.microsoft.com/office/drawing/2014/main" id="{5534011B-DA61-4E1D-BDAD-BC8A29F5E84A}"/>
+              </a:ext>
+            </a:extLst>
+          </p:cNvPr>
+          <p:cNvSpPr>
+            <a:spLocks xmlns:a="http://schemas.openxmlformats.org/drawingml/2006/main" noGrp="1"/>
+          </p:cNvSpPr>
+          <p:nvPr/>
+        </p:nvSpPr>
+        <p:spPr>
+          <a:xfrm xmlns:a="http://schemas.openxmlformats.org/drawingml/2006/main">
+            <a:off x="619125" y="6096000"/>
+            <a:ext cx="10858500" cy="428625"/>
+          </a:xfrm>
+          <a:prstGeom xmlns:a="http://schemas.openxmlformats.org/drawingml/2006/main" prst="rect">
+            <a:avLst/>
+          </a:prstGeom>
+          <a:noFill xmlns:a="http://schemas.openxmlformats.org/drawingml/2006/main"/>
+          <a:ln xmlns:a="http://schemas.openxmlformats.org/drawingml/2006/main" w="0">
+            <a:noFill/>
+          </a:ln>
+        </p:spPr>
+        <p:txBody>
+          <a:bodyPr xmlns:a="http://schemas.openxmlformats.org/drawingml/2006/main">
+            <a:noAutofit/>
+          </a:bodyPr>
+          <a:lstStyle xmlns:a="http://schemas.openxmlformats.org/drawingml/2006/main"/>
+          <a:p xmlns:a="http://schemas.openxmlformats.org/drawingml/2006/main">
+            <a:pPr>
+              <a:defRPr sz="1725" b="0">
+                <a:solidFill>
+                  <a:srgbClr val="71718B"/>
+                </a:solidFill>
+                <a:latin typeface="Arial"/>
+                <a:ea typeface="Arial"/>
+                <a:cs typeface="Arial"/>
+              </a:defRPr>
+            </a:pPr>
+            <a:r>
+              <a:rPr sz="1725" b="0">
+                <a:solidFill>
+                  <a:srgbClr val="71718B"/>
+                </a:solidFill>
+                <a:latin typeface="Arial"/>
+                <a:ea typeface="Arial"/>
+                <a:cs typeface="Arial"/>
+              </a:rPr>
+              <a:t>make evidence captures receipts without repeating model calls</a:t>
             </a:r>
           </a:p>
         </p:txBody>
@@ -3817,7 +3897,7 @@
     </p:spTree>
     <p:extLst>
       <p:ext uri="{BB962C8B-B14F-4D97-AF65-F5344CB8AC3E}">
-        <p14:creationId xmlns:p14="http://schemas.microsoft.com/office/powerpoint/2010/main" val="152099927"/>
+        <p14:creationId xmlns:p14="http://schemas.microsoft.com/office/powerpoint/2010/main" val="994227051"/>
       </p:ext>
     </p:extLst>
   </p:cSld>
@@ -3848,7 +3928,7 @@
           <p:cNvPr id="6" name="">
             <a:extLst xmlns:a="http://schemas.openxmlformats.org/drawingml/2006/main">
               <a:ext uri="{FF2B5EF4-FFF2-40B4-BE49-F238E27FC236}">
-                <a16:creationId xmlns:a16="http://schemas.microsoft.com/office/drawing/2014/main" id="{74BA5E91-E924-4F83-99B3-AF0ECD57B9B7}"/>
+                <a16:creationId xmlns:a16="http://schemas.microsoft.com/office/drawing/2014/main" id="{E8E3B4C1-059B-474E-B354-9EDE813DCA96}"/>
               </a:ext>
             </a:extLst>
           </p:cNvPr>
@@ -3895,7 +3975,7 @@
                 <a:ea typeface="Arial"/>
                 <a:cs typeface="Arial"/>
               </a:rPr>
-              <a:t>Next: calibrated scoring and generation</a:t>
+              <a:t>MS3: adaptation and scoring evaluation</a:t>
             </a:r>
           </a:p>
         </p:txBody>
@@ -3905,7 +3985,7 @@
           <p:cNvPr id="2" name="">
             <a:extLst xmlns:a="http://schemas.openxmlformats.org/drawingml/2006/main">
               <a:ext uri="{FF2B5EF4-FFF2-40B4-BE49-F238E27FC236}">
-                <a16:creationId xmlns:a16="http://schemas.microsoft.com/office/drawing/2014/main" id="{81754C5A-7A15-4F5E-86D2-0CBB7A315E5F}"/>
+                <a16:creationId xmlns:a16="http://schemas.microsoft.com/office/drawing/2014/main" id="{D4C99576-B329-4D02-A2A3-57A875196D9E}"/>
               </a:ext>
             </a:extLst>
           </p:cNvPr>
@@ -3916,7 +3996,7 @@
         </p:nvSpPr>
         <p:spPr>
           <a:xfrm xmlns:a="http://schemas.openxmlformats.org/drawingml/2006/main">
-            <a:off x="619125" y="1571625"/>
+            <a:off x="619125" y="1524000"/>
             <a:ext cx="10858500" cy="619125"/>
           </a:xfrm>
           <a:prstGeom xmlns:a="http://schemas.openxmlformats.org/drawingml/2006/main" prst="rect">
@@ -3952,7 +4032,7 @@
                 <a:ea typeface="Arial"/>
                 <a:cs typeface="Arial"/>
               </a:rPr>
-              <a:t>Data approval and leakage audit</a:t>
+              <a:t>Reliable Task 2 data and leakage checks</a:t>
             </a:r>
           </a:p>
         </p:txBody>
@@ -3962,7 +4042,7 @@
           <p:cNvPr id="3" name="">
             <a:extLst xmlns:a="http://schemas.openxmlformats.org/drawingml/2006/main">
               <a:ext uri="{FF2B5EF4-FFF2-40B4-BE49-F238E27FC236}">
-                <a16:creationId xmlns:a16="http://schemas.microsoft.com/office/drawing/2014/main" id="{9D121A27-4C34-4B38-A37D-2F7374E7050B}"/>
+                <a16:creationId xmlns:a16="http://schemas.microsoft.com/office/drawing/2014/main" id="{CF589312-3056-4C93-9DF8-DE226E40C24B}"/>
               </a:ext>
             </a:extLst>
           </p:cNvPr>
@@ -3973,7 +4053,7 @@
         </p:nvSpPr>
         <p:spPr>
           <a:xfrm xmlns:a="http://schemas.openxmlformats.org/drawingml/2006/main">
-            <a:off x="619125" y="2619375"/>
+            <a:off x="619125" y="2571750"/>
             <a:ext cx="10858500" cy="619125"/>
           </a:xfrm>
           <a:prstGeom xmlns:a="http://schemas.openxmlformats.org/drawingml/2006/main" prst="rect">
@@ -4009,7 +4089,7 @@
                 <a:ea typeface="Arial"/>
                 <a:cs typeface="Arial"/>
               </a:rPr>
-              <a:t>General prompting vs rubric RAG vs LoRA adaptation</a:t>
+              <a:t>Prompting vs official RAG vs open-model LoRA</a:t>
             </a:r>
           </a:p>
         </p:txBody>
@@ -4019,7 +4099,7 @@
           <p:cNvPr id="4" name="">
             <a:extLst xmlns:a="http://schemas.openxmlformats.org/drawingml/2006/main">
               <a:ext uri="{FF2B5EF4-FFF2-40B4-BE49-F238E27FC236}">
-                <a16:creationId xmlns:a16="http://schemas.microsoft.com/office/drawing/2014/main" id="{B65CC7E8-77F0-40D7-94EE-3AC611CDE7BA}"/>
+                <a16:creationId xmlns:a16="http://schemas.microsoft.com/office/drawing/2014/main" id="{1015A234-0C55-4074-ACCC-0A5697A0400F}"/>
               </a:ext>
             </a:extLst>
           </p:cNvPr>
@@ -4030,7 +4110,7 @@
         </p:nvSpPr>
         <p:spPr>
           <a:xfrm xmlns:a="http://schemas.openxmlformats.org/drawingml/2006/main">
-            <a:off x="619125" y="3667125"/>
+            <a:off x="619125" y="3619500"/>
             <a:ext cx="10858500" cy="619125"/>
           </a:xfrm>
           <a:prstGeom xmlns:a="http://schemas.openxmlformats.org/drawingml/2006/main" prst="rect">
@@ -4066,7 +4146,7 @@
                 <a:ea typeface="Arial"/>
                 <a:cs typeface="Arial"/>
               </a:rPr>
-              <a:t>Criterion scores and passage-specific revision examples</a:t>
+              <a:t>Criterion agreement and repeated-run variance</a:t>
             </a:r>
           </a:p>
         </p:txBody>
@@ -4076,7 +4156,7 @@
           <p:cNvPr id="5" name="">
             <a:extLst xmlns:a="http://schemas.openxmlformats.org/drawingml/2006/main">
               <a:ext uri="{FF2B5EF4-FFF2-40B4-BE49-F238E27FC236}">
-                <a16:creationId xmlns:a16="http://schemas.microsoft.com/office/drawing/2014/main" id="{52224FCF-172E-4719-942F-50678D13E38E}"/>
+                <a16:creationId xmlns:a16="http://schemas.microsoft.com/office/drawing/2014/main" id="{528074FD-11B6-4D6E-9507-4ACF65C09EB4}"/>
               </a:ext>
             </a:extLst>
           </p:cNvPr>
@@ -4087,7 +4167,7 @@
         </p:nvSpPr>
         <p:spPr>
           <a:xfrm xmlns:a="http://schemas.openxmlformats.org/drawingml/2006/main">
-            <a:off x="619125" y="4714875"/>
+            <a:off x="619125" y="4667250"/>
             <a:ext cx="10858500" cy="619125"/>
           </a:xfrm>
           <a:prstGeom xmlns:a="http://schemas.openxmlformats.org/drawingml/2006/main" prst="rect">
@@ -4123,7 +4203,7 @@
                 <a:ea typeface="Arial"/>
                 <a:cs typeface="Arial"/>
               </a:rPr>
-              <a:t>Target-band essay generation with a separate scoring pass</a:t>
+              <a:t>Target-band deviation, latency and inference cost</a:t>
             </a:r>
           </a:p>
         </p:txBody>
@@ -4131,7 +4211,7 @@
     </p:spTree>
     <p:extLst>
       <p:ext uri="{BB962C8B-B14F-4D97-AF65-F5344CB8AC3E}">
-        <p14:creationId xmlns:p14="http://schemas.microsoft.com/office/powerpoint/2010/main" val="818877451"/>
+        <p14:creationId xmlns:p14="http://schemas.microsoft.com/office/powerpoint/2010/main" val="1266671397"/>
       </p:ext>
     </p:extLst>
   </p:cSld>

</xml_diff>